<commit_message>
docs: gercek replay ve tazelik kanitlarini guncelle
</commit_message>
<xml_diff>
--- a/presentation/Arf.pptx
+++ b/presentation/Arf.pptx
@@ -930,7 +930,7 @@
           <a:lstStyle/>
           <a:p>
             <a:r>
-              <a:t>Organizatörün sorusunu doğrudan cevaplayayım: veri bozulunca imza yok, yetkisiz imza BadSigner alıyor ve tüketilmiş onay tekrar kullanılınca AlreadyUsed devreye giriyor. Oracle anahtarı çalınırsa owner pause ve setOracle ile müdahale ediyor; yanlış alarm için zincirde parametrik eşik ve nominal Bonferroni düzeltmesi var, ancak gerçek yanlış alarm oranını ölçtüğümü söylemiyorum. LLM'e sadece yapısal veri gidiyor ve sayılar deterministik kalıyor; tek oracle güveni sürüyor, önceden verilmiş imzalar geçerlilik penceresinde kullanılabilir ve acil çıkış yolu yalnızca kavram, bu yüzden çoklu oracle ile eşik imza sonraki adım.</a:t>
+              <a:t>Organizatörün sorusunu doğrudan cevaplayayım: veri bozulunca imza yok, yetkisiz imza BadSigner alıyor ve replay için önce tazelik kontrol ediliyor: eski onay StaleScore, üç yüz saniyelik pencere içindeki tüketilmiş onay AlreadyUsed ile reddediliyor; her iki katman da gerçek tx ile ölçüldü. Oracle anahtarı çalınırsa owner pause ve setOracle ile müdahale ediyor; yanlış alarm için zincirde parametrik eşik ve nominal Bonferroni düzeltmesi var, ancak gerçek yanlış alarm oranını ölçtüğümü söylemiyorum. LLM'e sadece yapısal veri gidiyor ve sayılar deterministik kalıyor; tek oracle güveni sürüyor, önceden verilmiş imzalar geçerlilik penceresinde kullanılabilir ve acil çıkış yolu yalnızca kavram, bu yüzden çoklu oracle ile eşik imza sonraki adım.</a:t>
             </a:r>
           </a:p>
         </p:txBody>
@@ -1000,7 +1000,7 @@
           <a:lstStyle/>
           <a:p>
             <a:r>
-              <a:t>Zincirde IntentApproved, ExceedsSafeSize ve BadSigner gerçek işlem kayıtlarıyla gösterildi; AlreadyUsed ve StaleScore için elimizde şu anda yalnızca eth_call var, gerçek işlem hash'leri bekliyor. Kayıtlardaki zincir onayı yaklaşık iki saniye, LLM maliyeti koşu başına yaklaşık binde bir dolar ve bunlar örnek koşuların sonuçları; bu oturumda seksen iki Python testi geçti, on dört Solidity testi ise STATUS kaydından geliyor. Yirmi paritelik epizodik hafıza var ama tek oracle ve testnet sınırları sürüyor; ayrıca simülasyonun bir kez istemeden işlem gönderdiğini saklamıyorum, dry_run kilidi ve sekiz güvenlik testiyle bu yol kapatıldı.</a:t>
+              <a:t>Ana kanıt listesinde yedi gerçek tx var; IntentApproved ile demo kapsamındaki ExceedsSafeSize, BadSigner, AlreadyUsed ve StaleScore zincirde kaydedildi, taze replay kanıtı için bir USDT hazırlık işlemi ayrıca kullanıldı. Kontrat tazeliği replay kontrolünden önce denetlediği için eski kullanılmış onay StaleScore, geçerlilik penceresindeki kullanılmış onay AlreadyUsed alıyor; tablodaki bağlantılar bu gerçek işlemlere gidiyor. Güncel toplam seksen yedi Python testi burada ortam dosyası yüklemesi kapalı ve açık kontrat adresiyle geçti, on dört Solidity testi STATUS kaydı; yaklaşık iki saniye zincir onayı ve binde bir dolar LLM maliyeti örnek ölçümler, tek oracle ve testnet sınırları sürüyor.</a:t>
             </a:r>
           </a:p>
         </p:txBody>
@@ -7444,7 +7444,7 @@
         </p:nvGraphicFramePr>
         <p:xfrm>
           <a:off x="731520" y="1737360"/>
-          <a:ext cx="10789920" cy="4160520"/>
+          <a:ext cx="10789920" cy="4023360"/>
         </p:xfrm>
         <a:graphic>
           <a:graphicData uri="http://schemas.openxmlformats.org/drawingml/2006/table">
@@ -7456,7 +7456,7 @@
                 <a:gridCol w="3657600"/>
                 <a:gridCol w="7132320"/>
               </a:tblGrid>
-              <a:tr h="693420">
+              <a:tr h="670560">
                 <a:tc>
                   <a:txBody>
                     <a:bodyPr/>
@@ -7502,7 +7502,7 @@
                   </a:tcPr>
                 </a:tc>
               </a:tr>
-              <a:tr h="693420">
+              <a:tr h="670560">
                 <a:tc>
                   <a:txBody>
                     <a:bodyPr/>
@@ -7548,7 +7548,7 @@
                   </a:tcPr>
                 </a:tc>
               </a:tr>
-              <a:tr h="693420">
+              <a:tr h="670560">
                 <a:tc>
                   <a:txBody>
                     <a:bodyPr/>
@@ -7594,7 +7594,7 @@
                   </a:tcPr>
                 </a:tc>
               </a:tr>
-              <a:tr h="693420">
+              <a:tr h="670560">
                 <a:tc>
                   <a:txBody>
                     <a:bodyPr/>
@@ -7640,7 +7640,7 @@
                   </a:tcPr>
                 </a:tc>
               </a:tr>
-              <a:tr h="693420">
+              <a:tr h="670560">
                 <a:tc>
                   <a:txBody>
                     <a:bodyPr/>
@@ -7686,7 +7686,7 @@
                   </a:tcPr>
                 </a:tc>
               </a:tr>
-              <a:tr h="693420">
+              <a:tr h="670560">
                 <a:tc>
                   <a:txBody>
                     <a:bodyPr/>
@@ -7699,7 +7699,7 @@
                           </a:solidFill>
                           <a:latin typeface="Arial"/>
                         </a:rPr>
-                        <a:t>Onay tekrar kullanılır</a:t>
+                        <a:t>Taze tekrar / eski onay</a:t>
                       </a:r>
                     </a:p>
                   </a:txBody>
@@ -7721,7 +7721,7 @@
                           </a:solidFill>
                           <a:latin typeface="Arial"/>
                         </a:rPr>
-                        <a:t>AlreadyUsed; gerçek tx [BEKLİYOR]</a:t>
+                        <a:t>AlreadyUsed / StaleScore: gerçek tx</a:t>
                       </a:r>
                     </a:p>
                   </a:txBody>
@@ -7744,8 +7744,8 @@
         </p:nvSpPr>
         <p:spPr>
           <a:xfrm>
-            <a:off x="777240" y="5989320"/>
-            <a:ext cx="10607040" cy="274320"/>
+            <a:off x="777240" y="5852160"/>
+            <a:ext cx="10607040" cy="502920"/>
           </a:xfrm>
           <a:prstGeom prst="rect">
             <a:avLst/>
@@ -7764,13 +7764,13 @@
               </a:spcAft>
             </a:pPr>
             <a:r>
-              <a:rPr sz="1600" b="0">
-                <a:solidFill>
-                  <a:srgbClr val="B6C4D1"/>
+              <a:rPr sz="2000" b="0">
+                <a:solidFill>
+                  <a:srgbClr val="62E4CD"/>
                 </a:solidFill>
                 <a:latin typeface="Arial"/>
               </a:rPr>
-              <a:t>Acil çıkış / reduce-only bypass: yalnızca kavram.</a:t>
+              <a:t>Tazelik önce: eski onay StaleScore, taze tekrar AlreadyUsed.</a:t>
             </a:r>
           </a:p>
         </p:txBody>
@@ -7961,16 +7961,417 @@
           </a:p>
         </p:txBody>
       </p:sp>
-      <p:sp>
-        <p:nvSpPr>
-          <p:cNvPr id="6" name="TextBox 5"/>
+      <p:graphicFrame>
+        <p:nvGraphicFramePr>
+          <p:cNvPr id="6" name="Table 5"/>
+          <p:cNvGraphicFramePr>
+            <a:graphicFrameLocks noGrp="1"/>
+          </p:cNvGraphicFramePr>
+          <p:nvPr/>
+        </p:nvGraphicFramePr>
+        <p:xfrm>
+          <a:off x="731520" y="1691640"/>
+          <a:ext cx="10789920" cy="3474720"/>
+        </p:xfrm>
+        <a:graphic>
+          <a:graphicData uri="http://schemas.openxmlformats.org/drawingml/2006/table">
+            <a:tbl>
+              <a:tblPr firstRow="1" bandRow="1">
+                <a:tableStyleId>{5C22544A-7EE6-4342-B048-85BDC9FD1C3A}</a:tableStyleId>
+              </a:tblPr>
+              <a:tblGrid>
+                <a:gridCol w="5943600"/>
+                <a:gridCol w="4846320"/>
+              </a:tblGrid>
+              <a:tr h="434340">
+                <a:tc>
+                  <a:txBody>
+                    <a:bodyPr/>
+                    <a:lstStyle/>
+                    <a:p>
+                      <a:r>
+                        <a:rPr sz="2000" b="1">
+                          <a:solidFill>
+                            <a:srgbClr val="F4F7FA"/>
+                          </a:solidFill>
+                          <a:latin typeface="Arial"/>
+                        </a:rPr>
+                        <a:t>7 gerçek tx / ana kanıt listesi</a:t>
+                      </a:r>
+                    </a:p>
+                  </a:txBody>
+                  <a:tcPr marL="146304" marT="27432" marB="27432" anchor="ctr">
+                    <a:solidFill>
+                      <a:srgbClr val="25483F"/>
+                    </a:solidFill>
+                  </a:tcPr>
+                </a:tc>
+                <a:tc>
+                  <a:txBody>
+                    <a:bodyPr/>
+                    <a:lstStyle/>
+                    <a:p>
+                      <a:r>
+                        <a:rPr sz="2000" b="1">
+                          <a:solidFill>
+                            <a:srgbClr val="F4F7FA"/>
+                          </a:solidFill>
+                          <a:latin typeface="Arial"/>
+                        </a:rPr>
+                        <a:t>Fuji işlem bağlantısı</a:t>
+                      </a:r>
+                    </a:p>
+                  </a:txBody>
+                  <a:tcPr marL="146304" marT="27432" marB="27432" anchor="ctr">
+                    <a:solidFill>
+                      <a:srgbClr val="25483F"/>
+                    </a:solidFill>
+                  </a:tcPr>
+                </a:tc>
+              </a:tr>
+              <a:tr h="434340">
+                <a:tc>
+                  <a:txBody>
+                    <a:bodyPr/>
+                    <a:lstStyle/>
+                    <a:p>
+                      <a:r>
+                        <a:rPr sz="2000" b="0">
+                          <a:solidFill>
+                            <a:srgbClr val="F4F7FA"/>
+                          </a:solidFill>
+                          <a:latin typeface="Arial"/>
+                        </a:rPr>
+                        <a:t>IntentApproved / ilk kontrol</a:t>
+                      </a:r>
+                    </a:p>
+                  </a:txBody>
+                  <a:tcPr marL="146304" marT="27432" marB="27432" anchor="ctr">
+                    <a:solidFill>
+                      <a:srgbClr val="1C2B39"/>
+                    </a:solidFill>
+                  </a:tcPr>
+                </a:tc>
+                <a:tc>
+                  <a:txBody>
+                    <a:bodyPr/>
+                    <a:lstStyle/>
+                    <a:p>
+                      <a:r>
+                        <a:rPr sz="2000" b="0">
+                          <a:solidFill>
+                            <a:srgbClr val="62E4CD"/>
+                          </a:solidFill>
+                          <a:latin typeface="Arial"/>
+                          <a:hlinkClick r:id="rId3"/>
+                        </a:rPr>
+                        <a:t>0x7bef94f297de…71ba5173</a:t>
+                      </a:r>
+                    </a:p>
+                  </a:txBody>
+                  <a:tcPr marL="146304" marT="27432" marB="27432" anchor="ctr">
+                    <a:solidFill>
+                      <a:srgbClr val="1C2B39"/>
+                    </a:solidFill>
+                  </a:tcPr>
+                </a:tc>
+              </a:tr>
+              <a:tr h="434340">
+                <a:tc>
+                  <a:txBody>
+                    <a:bodyPr/>
+                    <a:lstStyle/>
+                    <a:p>
+                      <a:r>
+                        <a:rPr sz="2000" b="0">
+                          <a:solidFill>
+                            <a:srgbClr val="F4F7FA"/>
+                          </a:solidFill>
+                          <a:latin typeface="Arial"/>
+                        </a:rPr>
+                        <a:t>IntentApproved / agent</a:t>
+                      </a:r>
+                    </a:p>
+                  </a:txBody>
+                  <a:tcPr marL="146304" marT="27432" marB="27432" anchor="ctr">
+                    <a:solidFill>
+                      <a:srgbClr val="1C2B39"/>
+                    </a:solidFill>
+                  </a:tcPr>
+                </a:tc>
+                <a:tc>
+                  <a:txBody>
+                    <a:bodyPr/>
+                    <a:lstStyle/>
+                    <a:p>
+                      <a:r>
+                        <a:rPr sz="2000" b="0">
+                          <a:solidFill>
+                            <a:srgbClr val="62E4CD"/>
+                          </a:solidFill>
+                          <a:latin typeface="Arial"/>
+                          <a:hlinkClick r:id="rId4"/>
+                        </a:rPr>
+                        <a:t>0xa5798d597f00…5eaacbbe</a:t>
+                      </a:r>
+                    </a:p>
+                  </a:txBody>
+                  <a:tcPr marL="146304" marT="27432" marB="27432" anchor="ctr">
+                    <a:solidFill>
+                      <a:srgbClr val="1C2B39"/>
+                    </a:solidFill>
+                  </a:tcPr>
+                </a:tc>
+              </a:tr>
+              <a:tr h="434340">
+                <a:tc>
+                  <a:txBody>
+                    <a:bodyPr/>
+                    <a:lstStyle/>
+                    <a:p>
+                      <a:r>
+                        <a:rPr sz="2000" b="0">
+                          <a:solidFill>
+                            <a:srgbClr val="F4F7FA"/>
+                          </a:solidFill>
+                          <a:latin typeface="Arial"/>
+                        </a:rPr>
+                        <a:t>ExceedsSafeSize / ilk kontrol</a:t>
+                      </a:r>
+                    </a:p>
+                  </a:txBody>
+                  <a:tcPr marL="146304" marT="27432" marB="27432" anchor="ctr">
+                    <a:solidFill>
+                      <a:srgbClr val="1C2B39"/>
+                    </a:solidFill>
+                  </a:tcPr>
+                </a:tc>
+                <a:tc>
+                  <a:txBody>
+                    <a:bodyPr/>
+                    <a:lstStyle/>
+                    <a:p>
+                      <a:r>
+                        <a:rPr sz="2000" b="0">
+                          <a:solidFill>
+                            <a:srgbClr val="62E4CD"/>
+                          </a:solidFill>
+                          <a:latin typeface="Arial"/>
+                          <a:hlinkClick r:id="rId5"/>
+                        </a:rPr>
+                        <a:t>0x175eaee2cdce…8f4bf0e5</a:t>
+                      </a:r>
+                    </a:p>
+                  </a:txBody>
+                  <a:tcPr marL="146304" marT="27432" marB="27432" anchor="ctr">
+                    <a:solidFill>
+                      <a:srgbClr val="1C2B39"/>
+                    </a:solidFill>
+                  </a:tcPr>
+                </a:tc>
+              </a:tr>
+              <a:tr h="434340">
+                <a:tc>
+                  <a:txBody>
+                    <a:bodyPr/>
+                    <a:lstStyle/>
+                    <a:p>
+                      <a:r>
+                        <a:rPr sz="2000" b="0">
+                          <a:solidFill>
+                            <a:srgbClr val="F4F7FA"/>
+                          </a:solidFill>
+                          <a:latin typeface="Arial"/>
+                        </a:rPr>
+                        <a:t>ExceedsSafeSize / agent</a:t>
+                      </a:r>
+                    </a:p>
+                  </a:txBody>
+                  <a:tcPr marL="146304" marT="27432" marB="27432" anchor="ctr">
+                    <a:solidFill>
+                      <a:srgbClr val="1C2B39"/>
+                    </a:solidFill>
+                  </a:tcPr>
+                </a:tc>
+                <a:tc>
+                  <a:txBody>
+                    <a:bodyPr/>
+                    <a:lstStyle/>
+                    <a:p>
+                      <a:r>
+                        <a:rPr sz="2000" b="0">
+                          <a:solidFill>
+                            <a:srgbClr val="62E4CD"/>
+                          </a:solidFill>
+                          <a:latin typeface="Arial"/>
+                          <a:hlinkClick r:id="rId6"/>
+                        </a:rPr>
+                        <a:t>0x80aeb84999c6…eb2667a6</a:t>
+                      </a:r>
+                    </a:p>
+                  </a:txBody>
+                  <a:tcPr marL="146304" marT="27432" marB="27432" anchor="ctr">
+                    <a:solidFill>
+                      <a:srgbClr val="1C2B39"/>
+                    </a:solidFill>
+                  </a:tcPr>
+                </a:tc>
+              </a:tr>
+              <a:tr h="434340">
+                <a:tc>
+                  <a:txBody>
+                    <a:bodyPr/>
+                    <a:lstStyle/>
+                    <a:p>
+                      <a:r>
+                        <a:rPr sz="2000" b="0">
+                          <a:solidFill>
+                            <a:srgbClr val="F4F7FA"/>
+                          </a:solidFill>
+                          <a:latin typeface="Arial"/>
+                        </a:rPr>
+                        <a:t>BadSigner</a:t>
+                      </a:r>
+                    </a:p>
+                  </a:txBody>
+                  <a:tcPr marL="146304" marT="27432" marB="27432" anchor="ctr">
+                    <a:solidFill>
+                      <a:srgbClr val="1C2B39"/>
+                    </a:solidFill>
+                  </a:tcPr>
+                </a:tc>
+                <a:tc>
+                  <a:txBody>
+                    <a:bodyPr/>
+                    <a:lstStyle/>
+                    <a:p>
+                      <a:r>
+                        <a:rPr sz="2000" b="0">
+                          <a:solidFill>
+                            <a:srgbClr val="62E4CD"/>
+                          </a:solidFill>
+                          <a:latin typeface="Arial"/>
+                          <a:hlinkClick r:id="rId7"/>
+                        </a:rPr>
+                        <a:t>0x0b05e13fa25c…11ede98e</a:t>
+                      </a:r>
+                    </a:p>
+                  </a:txBody>
+                  <a:tcPr marL="146304" marT="27432" marB="27432" anchor="ctr">
+                    <a:solidFill>
+                      <a:srgbClr val="1C2B39"/>
+                    </a:solidFill>
+                  </a:tcPr>
+                </a:tc>
+              </a:tr>
+              <a:tr h="434340">
+                <a:tc>
+                  <a:txBody>
+                    <a:bodyPr/>
+                    <a:lstStyle/>
+                    <a:p>
+                      <a:r>
+                        <a:rPr sz="2000" b="0">
+                          <a:solidFill>
+                            <a:srgbClr val="F4F7FA"/>
+                          </a:solidFill>
+                          <a:latin typeface="Arial"/>
+                        </a:rPr>
+                        <a:t>AlreadyUsed</a:t>
+                      </a:r>
+                    </a:p>
+                  </a:txBody>
+                  <a:tcPr marL="146304" marT="27432" marB="27432" anchor="ctr">
+                    <a:solidFill>
+                      <a:srgbClr val="1C2B39"/>
+                    </a:solidFill>
+                  </a:tcPr>
+                </a:tc>
+                <a:tc>
+                  <a:txBody>
+                    <a:bodyPr/>
+                    <a:lstStyle/>
+                    <a:p>
+                      <a:r>
+                        <a:rPr sz="2000" b="0">
+                          <a:solidFill>
+                            <a:srgbClr val="62E4CD"/>
+                          </a:solidFill>
+                          <a:latin typeface="Arial"/>
+                          <a:hlinkClick r:id="rId8"/>
+                        </a:rPr>
+                        <a:t>0xa1ad95144f81…fbf99a80</a:t>
+                      </a:r>
+                    </a:p>
+                  </a:txBody>
+                  <a:tcPr marL="146304" marT="27432" marB="27432" anchor="ctr">
+                    <a:solidFill>
+                      <a:srgbClr val="1C2B39"/>
+                    </a:solidFill>
+                  </a:tcPr>
+                </a:tc>
+              </a:tr>
+              <a:tr h="434340">
+                <a:tc>
+                  <a:txBody>
+                    <a:bodyPr/>
+                    <a:lstStyle/>
+                    <a:p>
+                      <a:r>
+                        <a:rPr sz="2000" b="0">
+                          <a:solidFill>
+                            <a:srgbClr val="F4F7FA"/>
+                          </a:solidFill>
+                          <a:latin typeface="Arial"/>
+                        </a:rPr>
+                        <a:t>StaleScore</a:t>
+                      </a:r>
+                    </a:p>
+                  </a:txBody>
+                  <a:tcPr marL="146304" marT="27432" marB="27432" anchor="ctr">
+                    <a:solidFill>
+                      <a:srgbClr val="1C2B39"/>
+                    </a:solidFill>
+                  </a:tcPr>
+                </a:tc>
+                <a:tc>
+                  <a:txBody>
+                    <a:bodyPr/>
+                    <a:lstStyle/>
+                    <a:p>
+                      <a:r>
+                        <a:rPr sz="2000" b="0">
+                          <a:solidFill>
+                            <a:srgbClr val="62E4CD"/>
+                          </a:solidFill>
+                          <a:latin typeface="Arial"/>
+                          <a:hlinkClick r:id="rId9"/>
+                        </a:rPr>
+                        <a:t>0x0b29025776a1…b91233a3</a:t>
+                      </a:r>
+                    </a:p>
+                  </a:txBody>
+                  <a:tcPr marL="146304" marT="27432" marB="27432" anchor="ctr">
+                    <a:solidFill>
+                      <a:srgbClr val="1C2B39"/>
+                    </a:solidFill>
+                  </a:tcPr>
+                </a:tc>
+              </a:tr>
+            </a:tbl>
+          </a:graphicData>
+        </a:graphic>
+      </p:graphicFrame>
+      <p:sp>
+        <p:nvSpPr>
+          <p:cNvPr id="7" name="TextBox 6"/>
           <p:cNvSpPr txBox="1"/>
           <p:nvPr/>
         </p:nvSpPr>
         <p:spPr>
           <a:xfrm>
-            <a:off x="685800" y="1737360"/>
-            <a:ext cx="320040" cy="411480"/>
+            <a:off x="777240" y="5340096"/>
+            <a:ext cx="10607040" cy="411480"/>
           </a:xfrm>
           <a:prstGeom prst="rect">
             <a:avLst/>
@@ -7989,27 +8390,27 @@
               </a:spcAft>
             </a:pPr>
             <a:r>
-              <a:rPr sz="2500" b="0">
-                <a:solidFill>
-                  <a:srgbClr val="62E4CD"/>
+              <a:rPr sz="2200" b="0">
+                <a:solidFill>
+                  <a:srgbClr val="F4F7FA"/>
                 </a:solidFill>
                 <a:latin typeface="Arial"/>
               </a:rPr>
-              <a:t>•</a:t>
-            </a:r>
-          </a:p>
-        </p:txBody>
-      </p:sp>
-      <p:sp>
-        <p:nvSpPr>
-          <p:cNvPr id="7" name="TextBox 6"/>
+              <a:t>Yaklaşık 2 sn zincir onayı; yaklaşık $0,001 / LLM koşusu</a:t>
+            </a:r>
+          </a:p>
+        </p:txBody>
+      </p:sp>
+      <p:sp>
+        <p:nvSpPr>
+          <p:cNvPr id="8" name="TextBox 7"/>
           <p:cNvSpPr txBox="1"/>
           <p:nvPr/>
         </p:nvSpPr>
         <p:spPr>
           <a:xfrm>
-            <a:off x="1078992" y="1737360"/>
-            <a:ext cx="10287000" cy="777240"/>
+            <a:off x="777240" y="5779008"/>
+            <a:ext cx="10607040" cy="411480"/>
           </a:xfrm>
           <a:prstGeom prst="rect">
             <a:avLst/>
@@ -8028,27 +8429,27 @@
               </a:spcAft>
             </a:pPr>
             <a:r>
-              <a:rPr sz="2500" b="0">
+              <a:rPr sz="2000" b="0">
                 <a:solidFill>
                   <a:srgbClr val="F4F7FA"/>
                 </a:solidFill>
                 <a:latin typeface="Arial"/>
               </a:rPr>
-              <a:t>Gerçek tx: IntentApproved, ExceedsSafeSize, BadSigner</a:t>
-            </a:r>
-          </a:p>
-        </p:txBody>
-      </p:sp>
-      <p:sp>
-        <p:nvSpPr>
-          <p:cNvPr id="8" name="TextBox 7"/>
+              <a:t>Python 87/87; Solidity 14/14 (STATUS); 20 parite epizodik hafıza</a:t>
+            </a:r>
+          </a:p>
+        </p:txBody>
+      </p:sp>
+      <p:sp>
+        <p:nvSpPr>
+          <p:cNvPr id="9" name="TextBox 8"/>
           <p:cNvSpPr txBox="1"/>
           <p:nvPr/>
         </p:nvSpPr>
         <p:spPr>
           <a:xfrm>
-            <a:off x="685800" y="2606039"/>
-            <a:ext cx="320040" cy="411480"/>
+            <a:off x="777240" y="6199632"/>
+            <a:ext cx="10607040" cy="228600"/>
           </a:xfrm>
           <a:prstGeom prst="rect">
             <a:avLst/>
@@ -8067,286 +8468,13 @@
               </a:spcAft>
             </a:pPr>
             <a:r>
-              <a:rPr sz="2500" b="0">
-                <a:solidFill>
-                  <a:srgbClr val="62E4CD"/>
+              <a:rPr sz="1400" b="0">
+                <a:solidFill>
+                  <a:srgbClr val="B6C4D1"/>
                 </a:solidFill>
                 <a:latin typeface="Arial"/>
               </a:rPr>
-              <a:t>•</a:t>
-            </a:r>
-          </a:p>
-        </p:txBody>
-      </p:sp>
-      <p:sp>
-        <p:nvSpPr>
-          <p:cNvPr id="9" name="TextBox 8"/>
-          <p:cNvSpPr txBox="1"/>
-          <p:nvPr/>
-        </p:nvSpPr>
-        <p:spPr>
-          <a:xfrm>
-            <a:off x="1078992" y="2606039"/>
-            <a:ext cx="10287000" cy="777240"/>
-          </a:xfrm>
-          <a:prstGeom prst="rect">
-            <a:avLst/>
-          </a:prstGeom>
-          <a:noFill/>
-        </p:spPr>
-        <p:txBody>
-          <a:bodyPr wrap="square" lIns="0" rIns="0" tIns="27432" bIns="27432">
-            <a:spAutoFit/>
-          </a:bodyPr>
-          <a:lstStyle/>
-          <a:p>
-            <a:pPr algn="l">
-              <a:spcAft>
-                <a:spcPts val="800"/>
-              </a:spcAft>
-            </a:pPr>
-            <a:r>
-              <a:rPr sz="2500" b="0">
-                <a:solidFill>
-                  <a:srgbClr val="F4F7FA"/>
-                </a:solidFill>
-                <a:latin typeface="Arial"/>
-              </a:rPr>
-              <a:t>Yaklaşık 2 sn zincir onayı; yaklaşık $0,001 / LLM koşusu</a:t>
-            </a:r>
-          </a:p>
-        </p:txBody>
-      </p:sp>
-      <p:sp>
-        <p:nvSpPr>
-          <p:cNvPr id="10" name="TextBox 9"/>
-          <p:cNvSpPr txBox="1"/>
-          <p:nvPr/>
-        </p:nvSpPr>
-        <p:spPr>
-          <a:xfrm>
-            <a:off x="685800" y="3474720"/>
-            <a:ext cx="320040" cy="411480"/>
-          </a:xfrm>
-          <a:prstGeom prst="rect">
-            <a:avLst/>
-          </a:prstGeom>
-          <a:noFill/>
-        </p:spPr>
-        <p:txBody>
-          <a:bodyPr wrap="square" lIns="0" rIns="0" tIns="27432" bIns="27432">
-            <a:spAutoFit/>
-          </a:bodyPr>
-          <a:lstStyle/>
-          <a:p>
-            <a:pPr algn="l">
-              <a:spcAft>
-                <a:spcPts val="800"/>
-              </a:spcAft>
-            </a:pPr>
-            <a:r>
-              <a:rPr sz="2500" b="0">
-                <a:solidFill>
-                  <a:srgbClr val="62E4CD"/>
-                </a:solidFill>
-                <a:latin typeface="Arial"/>
-              </a:rPr>
-              <a:t>•</a:t>
-            </a:r>
-          </a:p>
-        </p:txBody>
-      </p:sp>
-      <p:sp>
-        <p:nvSpPr>
-          <p:cNvPr id="11" name="TextBox 10"/>
-          <p:cNvSpPr txBox="1"/>
-          <p:nvPr/>
-        </p:nvSpPr>
-        <p:spPr>
-          <a:xfrm>
-            <a:off x="1078992" y="3474720"/>
-            <a:ext cx="10287000" cy="777240"/>
-          </a:xfrm>
-          <a:prstGeom prst="rect">
-            <a:avLst/>
-          </a:prstGeom>
-          <a:noFill/>
-        </p:spPr>
-        <p:txBody>
-          <a:bodyPr wrap="square" lIns="0" rIns="0" tIns="27432" bIns="27432">
-            <a:spAutoFit/>
-          </a:bodyPr>
-          <a:lstStyle/>
-          <a:p>
-            <a:pPr algn="l">
-              <a:spcAft>
-                <a:spcPts val="800"/>
-              </a:spcAft>
-            </a:pPr>
-            <a:r>
-              <a:rPr sz="2500" b="0">
-                <a:solidFill>
-                  <a:srgbClr val="F4F7FA"/>
-                </a:solidFill>
-                <a:latin typeface="Arial"/>
-              </a:rPr>
-              <a:t>Python 82/82 bu oturum; Solidity 14/14 STATUS kaydı</a:t>
-            </a:r>
-          </a:p>
-        </p:txBody>
-      </p:sp>
-      <p:sp>
-        <p:nvSpPr>
-          <p:cNvPr id="12" name="TextBox 11"/>
-          <p:cNvSpPr txBox="1"/>
-          <p:nvPr/>
-        </p:nvSpPr>
-        <p:spPr>
-          <a:xfrm>
-            <a:off x="685800" y="4343400"/>
-            <a:ext cx="320040" cy="411480"/>
-          </a:xfrm>
-          <a:prstGeom prst="rect">
-            <a:avLst/>
-          </a:prstGeom>
-          <a:noFill/>
-        </p:spPr>
-        <p:txBody>
-          <a:bodyPr wrap="square" lIns="0" rIns="0" tIns="27432" bIns="27432">
-            <a:spAutoFit/>
-          </a:bodyPr>
-          <a:lstStyle/>
-          <a:p>
-            <a:pPr algn="l">
-              <a:spcAft>
-                <a:spcPts val="800"/>
-              </a:spcAft>
-            </a:pPr>
-            <a:r>
-              <a:rPr sz="2500" b="0">
-                <a:solidFill>
-                  <a:srgbClr val="62E4CD"/>
-                </a:solidFill>
-                <a:latin typeface="Arial"/>
-              </a:rPr>
-              <a:t>•</a:t>
-            </a:r>
-          </a:p>
-        </p:txBody>
-      </p:sp>
-      <p:sp>
-        <p:nvSpPr>
-          <p:cNvPr id="13" name="TextBox 12"/>
-          <p:cNvSpPr txBox="1"/>
-          <p:nvPr/>
-        </p:nvSpPr>
-        <p:spPr>
-          <a:xfrm>
-            <a:off x="1078992" y="4343400"/>
-            <a:ext cx="10287000" cy="777240"/>
-          </a:xfrm>
-          <a:prstGeom prst="rect">
-            <a:avLst/>
-          </a:prstGeom>
-          <a:noFill/>
-        </p:spPr>
-        <p:txBody>
-          <a:bodyPr wrap="square" lIns="0" rIns="0" tIns="27432" bIns="27432">
-            <a:spAutoFit/>
-          </a:bodyPr>
-          <a:lstStyle/>
-          <a:p>
-            <a:pPr algn="l">
-              <a:spcAft>
-                <a:spcPts val="800"/>
-              </a:spcAft>
-            </a:pPr>
-            <a:r>
-              <a:rPr sz="2500" b="0">
-                <a:solidFill>
-                  <a:srgbClr val="F4F7FA"/>
-                </a:solidFill>
-                <a:latin typeface="Arial"/>
-              </a:rPr>
-              <a:t>20 parite epizodik hafıza; kayıt aralığı 60 sn</a:t>
-            </a:r>
-          </a:p>
-        </p:txBody>
-      </p:sp>
-      <p:sp>
-        <p:nvSpPr>
-          <p:cNvPr id="14" name="TextBox 13"/>
-          <p:cNvSpPr txBox="1"/>
-          <p:nvPr/>
-        </p:nvSpPr>
-        <p:spPr>
-          <a:xfrm>
-            <a:off x="777240" y="5349240"/>
-            <a:ext cx="10607040" cy="640080"/>
-          </a:xfrm>
-          <a:prstGeom prst="rect">
-            <a:avLst/>
-          </a:prstGeom>
-          <a:noFill/>
-        </p:spPr>
-        <p:txBody>
-          <a:bodyPr wrap="square" lIns="0" rIns="0" tIns="27432" bIns="27432">
-            <a:spAutoFit/>
-          </a:bodyPr>
-          <a:lstStyle/>
-          <a:p>
-            <a:pPr algn="l">
-              <a:spcAft>
-                <a:spcPts val="800"/>
-              </a:spcAft>
-            </a:pPr>
-            <a:r>
-              <a:rPr sz="2100" b="0">
-                <a:solidFill>
-                  <a:srgbClr val="FFC56D"/>
-                </a:solidFill>
-                <a:latin typeface="Arial"/>
-              </a:rPr>
-              <a:t>AlreadyUsed / StaleScore: eth_call; gerçek tx [BEKLİYOR].</a:t>
-            </a:r>
-          </a:p>
-        </p:txBody>
-      </p:sp>
-      <p:sp>
-        <p:nvSpPr>
-          <p:cNvPr id="15" name="TextBox 14"/>
-          <p:cNvSpPr txBox="1"/>
-          <p:nvPr/>
-        </p:nvSpPr>
-        <p:spPr>
-          <a:xfrm>
-            <a:off x="777240" y="5943600"/>
-            <a:ext cx="10607040" cy="320040"/>
-          </a:xfrm>
-          <a:prstGeom prst="rect">
-            <a:avLst/>
-          </a:prstGeom>
-          <a:noFill/>
-        </p:spPr>
-        <p:txBody>
-          <a:bodyPr wrap="square" lIns="0" rIns="0" tIns="27432" bIns="27432">
-            <a:spAutoFit/>
-          </a:bodyPr>
-          <a:lstStyle/>
-          <a:p>
-            <a:pPr algn="l">
-              <a:spcAft>
-                <a:spcPts val="800"/>
-              </a:spcAft>
-            </a:pPr>
-            <a:r>
-              <a:rPr sz="1600" b="0">
-                <a:solidFill>
-                  <a:srgbClr val="B6C4D1"/>
-                </a:solidFill>
-                <a:latin typeface="Arial"/>
-              </a:rPr>
-              <a:t>Sınır: tek oracle, testnet, varsayılan ağırlıklar; dolum hızı ölçülmüyor.</a:t>
+              <a:t>Sınır: tek oracle, testnet; ağırlıklar varsayım. 1 USDT hazırlık tx'i ayrıca README'de.</a:t>
             </a:r>
           </a:p>
         </p:txBody>

</xml_diff>

<commit_message>
docs: polish repository and remove presentation preparation files
</commit_message>
<xml_diff>
--- a/presentation/Arf.pptx
+++ b/presentation/Arf.pptx
@@ -467,703 +467,703 @@
 </file>
 
 <file path=ppt/notesSlides/notesSlide1.xml><?xml version="1.0" encoding="utf-8"?>
-<p:notes xmlns:a="http://schemas.openxmlformats.org/drawingml/2006/main" xmlns:p="http://schemas.openxmlformats.org/presentationml/2006/main" xmlns:r="http://schemas.openxmlformats.org/officeDocument/2006/relationships">
-  <p:cSld>
-    <p:spTree>
-      <p:nvGrpSpPr>
-        <p:cNvPr id="1" name=""/>
-        <p:cNvGrpSpPr/>
-        <p:nvPr/>
-      </p:nvGrpSpPr>
-      <p:grpSpPr>
-        <a:xfrm>
-          <a:off x="0" y="0"/>
-          <a:ext cx="0" cy="0"/>
-          <a:chOff x="0" y="0"/>
-          <a:chExt cx="0" cy="0"/>
-        </a:xfrm>
-      </p:grpSpPr>
-      <p:sp>
-        <p:nvSpPr>
-          <p:cNvPr id="2" name="Slide Image Placeholder 1"/>
-          <p:cNvSpPr>
-            <a:spLocks noGrp="1"/>
-          </p:cNvSpPr>
-          <p:nvPr>
-            <p:ph type="sldImg" idx="2"/>
-          </p:nvPr>
-        </p:nvSpPr>
-        <p:spPr/>
-      </p:sp>
-      <p:sp>
-        <p:nvSpPr>
-          <p:cNvPr id="3" name="Notes Placeholder 2"/>
-          <p:cNvSpPr>
-            <a:spLocks noGrp="1"/>
-          </p:cNvSpPr>
-          <p:nvPr>
-            <p:ph type="body" idx="3" sz="quarter"/>
-          </p:nvPr>
-        </p:nvSpPr>
-        <p:spPr/>
-        <p:txBody>
-          <a:bodyPr/>
-          <a:lstStyle/>
-          <a:p>
-            <a:r>
-              <a:t>Arf, AI trading agent'lar için işlem öncesi icra ve likidite kalkanı; ATK verisini Avalanche üzerindeki bir devre kesiciye bağlıyorum. Adı Cahit Arf ve Arf değişmezine gönderme yapıyor, çünkü sistem tek bir değişmezi koruyor: emir tutarı imzalı güvenli tutarı aşamaz. Bu sunumda problemi, kurduğum akışı ve kötü senaryoda ne olduğunu göstereceğim; canlı uygulama yerelde, internetteki paylaşılabilir sürüm ise açıkça etiketlenmiş kayıtlı bir simülasyon.</a:t>
-            </a:r>
-          </a:p>
-        </p:txBody>
-      </p:sp>
-      <p:sp>
-        <p:nvSpPr>
-          <p:cNvPr id="4" name="Slide Number Placeholder 3"/>
-          <p:cNvSpPr>
-            <a:spLocks noGrp="1"/>
-          </p:cNvSpPr>
-          <p:nvPr>
-            <p:ph type="sldNum" idx="5" sz="quarter"/>
-          </p:nvPr>
-        </p:nvSpPr>
-        <p:spPr/>
-      </p:sp>
-    </p:spTree>
-  </p:cSld>
-  <p:clrMapOvr>
-    <a:masterClrMapping/>
-  </p:clrMapOvr>
-</p:notes>
+<ns0:notes xmlns:ns0="http://schemas.openxmlformats.org/presentationml/2006/main" xmlns:ns1="http://schemas.openxmlformats.org/drawingml/2006/main">
+  <ns0:cSld>
+    <ns0:spTree>
+      <ns0:nvGrpSpPr>
+        <ns0:cNvPr id="1" name=""/>
+        <ns0:cNvGrpSpPr/>
+        <ns0:nvPr/>
+      </ns0:nvGrpSpPr>
+      <ns0:grpSpPr>
+        <ns1:xfrm>
+          <ns1:off x="0" y="0"/>
+          <ns1:ext cx="0" cy="0"/>
+          <ns1:chOff x="0" y="0"/>
+          <ns1:chExt cx="0" cy="0"/>
+        </ns1:xfrm>
+      </ns0:grpSpPr>
+      <ns0:sp>
+        <ns0:nvSpPr>
+          <ns0:cNvPr id="2" name="Slide Image Placeholder 1"/>
+          <ns0:cNvSpPr>
+            <ns1:spLocks noGrp="1"/>
+          </ns0:cNvSpPr>
+          <ns0:nvPr>
+            <ns0:ph type="sldImg" idx="2"/>
+          </ns0:nvPr>
+        </ns0:nvSpPr>
+        <ns0:spPr/>
+      </ns0:sp>
+      <ns0:sp>
+        <ns0:nvSpPr>
+          <ns0:cNvPr id="3" name="Notes Placeholder 2"/>
+          <ns0:cNvSpPr>
+            <ns1:spLocks noGrp="1"/>
+          </ns0:cNvSpPr>
+          <ns0:nvPr>
+            <ns0:ph type="body" idx="3" sz="quarter"/>
+          </ns0:nvPr>
+        </ns0:nvSpPr>
+        <ns0:spPr/>
+        <ns0:txBody>
+          <ns1:bodyPr/>
+          <ns1:lstStyle/>
+          <ns1:p>
+            <ns1:r>
+              <ns1:t/>
+            </ns1:r>
+          </ns1:p>
+        </ns0:txBody>
+      </ns0:sp>
+      <ns0:sp>
+        <ns0:nvSpPr>
+          <ns0:cNvPr id="4" name="Slide Number Placeholder 3"/>
+          <ns0:cNvSpPr>
+            <ns1:spLocks noGrp="1"/>
+          </ns0:cNvSpPr>
+          <ns0:nvPr>
+            <ns0:ph type="sldNum" idx="5" sz="quarter"/>
+          </ns0:nvPr>
+        </ns0:nvSpPr>
+        <ns0:spPr/>
+      </ns0:sp>
+    </ns0:spTree>
+  </ns0:cSld>
+  <ns0:clrMapOvr>
+    <ns1:masterClrMapping/>
+  </ns0:clrMapOvr>
+</ns0:notes>
 </file>
 
 <file path=ppt/notesSlides/notesSlide10.xml><?xml version="1.0" encoding="utf-8"?>
-<p:notes xmlns:a="http://schemas.openxmlformats.org/drawingml/2006/main" xmlns:p="http://schemas.openxmlformats.org/presentationml/2006/main" xmlns:r="http://schemas.openxmlformats.org/officeDocument/2006/relationships">
-  <p:cSld>
-    <p:spTree>
-      <p:nvGrpSpPr>
-        <p:cNvPr id="1" name=""/>
-        <p:cNvGrpSpPr/>
-        <p:nvPr/>
-      </p:nvGrpSpPr>
-      <p:grpSpPr>
-        <a:xfrm>
-          <a:off x="0" y="0"/>
-          <a:ext cx="0" cy="0"/>
-          <a:chOff x="0" y="0"/>
-          <a:chExt cx="0" cy="0"/>
-        </a:xfrm>
-      </p:grpSpPr>
-      <p:sp>
-        <p:nvSpPr>
-          <p:cNvPr id="2" name="Slide Image Placeholder 1"/>
-          <p:cNvSpPr>
-            <a:spLocks noGrp="1"/>
-          </p:cNvSpPr>
-          <p:nvPr>
-            <p:ph type="sldImg" idx="2"/>
-          </p:nvPr>
-        </p:nvSpPr>
-        <p:spPr/>
-      </p:sp>
-      <p:sp>
-        <p:nvSpPr>
-          <p:cNvPr id="3" name="Notes Placeholder 2"/>
-          <p:cNvSpPr>
-            <a:spLocks noGrp="1"/>
-          </p:cNvSpPr>
-          <p:nvPr>
-            <p:ph type="body" idx="3" sz="quarter"/>
-          </p:nvPr>
-        </p:nvSpPr>
-        <p:spPr/>
-        <p:txBody>
-          <a:bodyPr/>
-          <a:lstStyle/>
-          <a:p>
-            <a:r>
-              <a:t>Teşekkür ederim, Arf’ın amacı her emirden önce tahtanın taşıyabileceği tutarı görünür ve doğrulanabilir kılmak. GitHub bağlantısında kaynak kod ve gerçek işlem kanıtları, internet bağlantısında ise kayıtlı verilerle çalışan etkileşimli simülasyon var. Canlı sistemi yerelde göstermeye ve sorularınızı cevaplamaya hazırım.</a:t>
-            </a:r>
-          </a:p>
-        </p:txBody>
-      </p:sp>
-      <p:sp>
-        <p:nvSpPr>
-          <p:cNvPr id="4" name="Slide Number Placeholder 3"/>
-          <p:cNvSpPr>
-            <a:spLocks noGrp="1"/>
-          </p:cNvSpPr>
-          <p:nvPr>
-            <p:ph type="sldNum" idx="5" sz="quarter"/>
-          </p:nvPr>
-        </p:nvSpPr>
-        <p:spPr/>
-      </p:sp>
-    </p:spTree>
-  </p:cSld>
-  <p:clrMapOvr>
-    <a:masterClrMapping/>
-  </p:clrMapOvr>
-</p:notes>
+<ns0:notes xmlns:ns0="http://schemas.openxmlformats.org/presentationml/2006/main" xmlns:ns1="http://schemas.openxmlformats.org/drawingml/2006/main">
+  <ns0:cSld>
+    <ns0:spTree>
+      <ns0:nvGrpSpPr>
+        <ns0:cNvPr id="1" name=""/>
+        <ns0:cNvGrpSpPr/>
+        <ns0:nvPr/>
+      </ns0:nvGrpSpPr>
+      <ns0:grpSpPr>
+        <ns1:xfrm>
+          <ns1:off x="0" y="0"/>
+          <ns1:ext cx="0" cy="0"/>
+          <ns1:chOff x="0" y="0"/>
+          <ns1:chExt cx="0" cy="0"/>
+        </ns1:xfrm>
+      </ns0:grpSpPr>
+      <ns0:sp>
+        <ns0:nvSpPr>
+          <ns0:cNvPr id="2" name="Slide Image Placeholder 1"/>
+          <ns0:cNvSpPr>
+            <ns1:spLocks noGrp="1"/>
+          </ns0:cNvSpPr>
+          <ns0:nvPr>
+            <ns0:ph type="sldImg" idx="2"/>
+          </ns0:nvPr>
+        </ns0:nvSpPr>
+        <ns0:spPr/>
+      </ns0:sp>
+      <ns0:sp>
+        <ns0:nvSpPr>
+          <ns0:cNvPr id="3" name="Notes Placeholder 2"/>
+          <ns0:cNvSpPr>
+            <ns1:spLocks noGrp="1"/>
+          </ns0:cNvSpPr>
+          <ns0:nvPr>
+            <ns0:ph type="body" idx="3" sz="quarter"/>
+          </ns0:nvPr>
+        </ns0:nvSpPr>
+        <ns0:spPr/>
+        <ns0:txBody>
+          <ns1:bodyPr/>
+          <ns1:lstStyle/>
+          <ns1:p>
+            <ns1:r>
+              <ns1:t/>
+            </ns1:r>
+          </ns1:p>
+        </ns0:txBody>
+      </ns0:sp>
+      <ns0:sp>
+        <ns0:nvSpPr>
+          <ns0:cNvPr id="4" name="Slide Number Placeholder 3"/>
+          <ns0:cNvSpPr>
+            <ns1:spLocks noGrp="1"/>
+          </ns0:cNvSpPr>
+          <ns0:nvPr>
+            <ns0:ph type="sldNum" idx="5" sz="quarter"/>
+          </ns0:nvPr>
+        </ns0:nvSpPr>
+        <ns0:spPr/>
+      </ns0:sp>
+    </ns0:spTree>
+  </ns0:cSld>
+  <ns0:clrMapOvr>
+    <ns1:masterClrMapping/>
+  </ns0:clrMapOvr>
+</ns0:notes>
 </file>
 
 <file path=ppt/notesSlides/notesSlide2.xml><?xml version="1.0" encoding="utf-8"?>
-<p:notes xmlns:a="http://schemas.openxmlformats.org/drawingml/2006/main" xmlns:p="http://schemas.openxmlformats.org/presentationml/2006/main" xmlns:r="http://schemas.openxmlformats.org/officeDocument/2006/relationships">
-  <p:cSld>
-    <p:spTree>
-      <p:nvGrpSpPr>
-        <p:cNvPr id="1" name=""/>
-        <p:cNvGrpSpPr/>
-        <p:nvPr/>
-      </p:nvGrpSpPr>
-      <p:grpSpPr>
-        <a:xfrm>
-          <a:off x="0" y="0"/>
-          <a:ext cx="0" cy="0"/>
-          <a:chOff x="0" y="0"/>
-          <a:chExt cx="0" cy="0"/>
-        </a:xfrm>
-      </p:grpSpPr>
-      <p:sp>
-        <p:nvSpPr>
-          <p:cNvPr id="2" name="Slide Image Placeholder 1"/>
-          <p:cNvSpPr>
-            <a:spLocks noGrp="1"/>
-          </p:cNvSpPr>
-          <p:nvPr>
-            <p:ph type="sldImg" idx="2"/>
-          </p:nvPr>
-        </p:nvSpPr>
-        <p:spPr/>
-      </p:sp>
-      <p:sp>
-        <p:nvSpPr>
-          <p:cNvPr id="3" name="Notes Placeholder 2"/>
-          <p:cNvSpPr>
-            <a:spLocks noGrp="1"/>
-          </p:cNvSpPr>
-          <p:nvPr>
-            <p:ph type="body" idx="3" sz="quarter"/>
-          </p:nvPr>
-        </p:nvSpPr>
-        <p:spPr/>
-        <p:txBody>
-          <a:bodyPr/>
-          <a:lstStyle/>
-          <a:p>
-            <a:r>
-              <a:t>ATK ile binlerce trading agent yazılacak; tahtanın emri kaldırıp kaldıramayacağını bilmeyen agent kendini batırır. Hackathon ölçüm notundaki BIGTIME örneğinde bin USDT için kayma on virgül sekiz baz puanken on bin USDT için bin iki yüz seksen dört baz puan; tutar on kat, kayma oranı yüz kattan fazla büyüyor. Bunlar 17 Ekim tarihli tek bir tahta örneği, canlı fiyat veya genel performans garantisi değil; bu nedenle kontrolün her emirden önce tekrarlanması gerekiyor.</a:t>
-            </a:r>
-          </a:p>
-        </p:txBody>
-      </p:sp>
-      <p:sp>
-        <p:nvSpPr>
-          <p:cNvPr id="4" name="Slide Number Placeholder 3"/>
-          <p:cNvSpPr>
-            <a:spLocks noGrp="1"/>
-          </p:cNvSpPr>
-          <p:nvPr>
-            <p:ph type="sldNum" idx="5" sz="quarter"/>
-          </p:nvPr>
-        </p:nvSpPr>
-        <p:spPr/>
-      </p:sp>
-    </p:spTree>
-  </p:cSld>
-  <p:clrMapOvr>
-    <a:masterClrMapping/>
-  </p:clrMapOvr>
-</p:notes>
+<ns0:notes xmlns:ns0="http://schemas.openxmlformats.org/presentationml/2006/main" xmlns:ns1="http://schemas.openxmlformats.org/drawingml/2006/main">
+  <ns0:cSld>
+    <ns0:spTree>
+      <ns0:nvGrpSpPr>
+        <ns0:cNvPr id="1" name=""/>
+        <ns0:cNvGrpSpPr/>
+        <ns0:nvPr/>
+      </ns0:nvGrpSpPr>
+      <ns0:grpSpPr>
+        <ns1:xfrm>
+          <ns1:off x="0" y="0"/>
+          <ns1:ext cx="0" cy="0"/>
+          <ns1:chOff x="0" y="0"/>
+          <ns1:chExt cx="0" cy="0"/>
+        </ns1:xfrm>
+      </ns0:grpSpPr>
+      <ns0:sp>
+        <ns0:nvSpPr>
+          <ns0:cNvPr id="2" name="Slide Image Placeholder 1"/>
+          <ns0:cNvSpPr>
+            <ns1:spLocks noGrp="1"/>
+          </ns0:cNvSpPr>
+          <ns0:nvPr>
+            <ns0:ph type="sldImg" idx="2"/>
+          </ns0:nvPr>
+        </ns0:nvSpPr>
+        <ns0:spPr/>
+      </ns0:sp>
+      <ns0:sp>
+        <ns0:nvSpPr>
+          <ns0:cNvPr id="3" name="Notes Placeholder 2"/>
+          <ns0:cNvSpPr>
+            <ns1:spLocks noGrp="1"/>
+          </ns0:cNvSpPr>
+          <ns0:nvPr>
+            <ns0:ph type="body" idx="3" sz="quarter"/>
+          </ns0:nvPr>
+        </ns0:nvSpPr>
+        <ns0:spPr/>
+        <ns0:txBody>
+          <ns1:bodyPr/>
+          <ns1:lstStyle/>
+          <ns1:p>
+            <ns1:r>
+              <ns1:t/>
+            </ns1:r>
+          </ns1:p>
+        </ns0:txBody>
+      </ns0:sp>
+      <ns0:sp>
+        <ns0:nvSpPr>
+          <ns0:cNvPr id="4" name="Slide Number Placeholder 3"/>
+          <ns0:cNvSpPr>
+            <ns1:spLocks noGrp="1"/>
+          </ns0:cNvSpPr>
+          <ns0:nvPr>
+            <ns0:ph type="sldNum" idx="5" sz="quarter"/>
+          </ns0:nvPr>
+        </ns0:nvSpPr>
+        <ns0:spPr/>
+      </ns0:sp>
+    </ns0:spTree>
+  </ns0:cSld>
+  <ns0:clrMapOvr>
+    <ns1:masterClrMapping/>
+  </ns0:clrMapOvr>
+</ns0:notes>
 </file>
 
 <file path=ppt/notesSlides/notesSlide3.xml><?xml version="1.0" encoding="utf-8"?>
-<p:notes xmlns:a="http://schemas.openxmlformats.org/drawingml/2006/main" xmlns:p="http://schemas.openxmlformats.org/presentationml/2006/main" xmlns:r="http://schemas.openxmlformats.org/officeDocument/2006/relationships">
-  <p:cSld>
-    <p:spTree>
-      <p:nvGrpSpPr>
-        <p:cNvPr id="1" name=""/>
-        <p:cNvGrpSpPr/>
-        <p:nvPr/>
-      </p:nvGrpSpPr>
-      <p:grpSpPr>
-        <a:xfrm>
-          <a:off x="0" y="0"/>
-          <a:ext cx="0" cy="0"/>
-          <a:chOff x="0" y="0"/>
-          <a:chExt cx="0" cy="0"/>
-        </a:xfrm>
-      </p:grpSpPr>
-      <p:sp>
-        <p:nvSpPr>
-          <p:cNvPr id="2" name="Slide Image Placeholder 1"/>
-          <p:cNvSpPr>
-            <a:spLocks noGrp="1"/>
-          </p:cNvSpPr>
-          <p:nvPr>
-            <p:ph type="sldImg" idx="2"/>
-          </p:nvPr>
-        </p:nvSpPr>
-        <p:spPr/>
-      </p:sp>
-      <p:sp>
-        <p:nvSpPr>
-          <p:cNvPr id="3" name="Notes Placeholder 2"/>
-          <p:cNvSpPr>
-            <a:spLocks noGrp="1"/>
-          </p:cNvSpPr>
-          <p:nvPr>
-            <p:ph type="body" idx="3" sz="quarter"/>
-          </p:nvPr>
-        </p:nvSpPr>
-        <p:spPr/>
-        <p:txBody>
-          <a:bodyPr/>
-          <a:lstStyle/>
-          <a:p>
-            <a:r>
-              <a:t>Arf’ın sorduğu soru basit: bu emir bu tahtada kaça patlar ve en fazla ne kadarlık emir güvenli? check_execution sembolü, yönü ve tutarı alır; deterministik risk skorunu, güvenli tutarı ve gerekiyorsa bölme önerisini üretir, taze sonuç oracle tarafından imzalanır ve kontrat bu sınırı uygular. Buradaki güvenli tutar anlık tahta ölçümüdür, gelecekteki dolum garantisi değildir ve kontrat OKX üzerinde kendisi emir yürütmez.</a:t>
-            </a:r>
-          </a:p>
-        </p:txBody>
-      </p:sp>
-      <p:sp>
-        <p:nvSpPr>
-          <p:cNvPr id="4" name="Slide Number Placeholder 3"/>
-          <p:cNvSpPr>
-            <a:spLocks noGrp="1"/>
-          </p:cNvSpPr>
-          <p:nvPr>
-            <p:ph type="sldNum" idx="5" sz="quarter"/>
-          </p:nvPr>
-        </p:nvSpPr>
-        <p:spPr/>
-      </p:sp>
-    </p:spTree>
-  </p:cSld>
-  <p:clrMapOvr>
-    <a:masterClrMapping/>
-  </p:clrMapOvr>
-</p:notes>
+<ns0:notes xmlns:ns0="http://schemas.openxmlformats.org/presentationml/2006/main" xmlns:ns1="http://schemas.openxmlformats.org/drawingml/2006/main">
+  <ns0:cSld>
+    <ns0:spTree>
+      <ns0:nvGrpSpPr>
+        <ns0:cNvPr id="1" name=""/>
+        <ns0:cNvGrpSpPr/>
+        <ns0:nvPr/>
+      </ns0:nvGrpSpPr>
+      <ns0:grpSpPr>
+        <ns1:xfrm>
+          <ns1:off x="0" y="0"/>
+          <ns1:ext cx="0" cy="0"/>
+          <ns1:chOff x="0" y="0"/>
+          <ns1:chExt cx="0" cy="0"/>
+        </ns1:xfrm>
+      </ns0:grpSpPr>
+      <ns0:sp>
+        <ns0:nvSpPr>
+          <ns0:cNvPr id="2" name="Slide Image Placeholder 1"/>
+          <ns0:cNvSpPr>
+            <ns1:spLocks noGrp="1"/>
+          </ns0:cNvSpPr>
+          <ns0:nvPr>
+            <ns0:ph type="sldImg" idx="2"/>
+          </ns0:nvPr>
+        </ns0:nvSpPr>
+        <ns0:spPr/>
+      </ns0:sp>
+      <ns0:sp>
+        <ns0:nvSpPr>
+          <ns0:cNvPr id="3" name="Notes Placeholder 2"/>
+          <ns0:cNvSpPr>
+            <ns1:spLocks noGrp="1"/>
+          </ns0:cNvSpPr>
+          <ns0:nvPr>
+            <ns0:ph type="body" idx="3" sz="quarter"/>
+          </ns0:nvPr>
+        </ns0:nvSpPr>
+        <ns0:spPr/>
+        <ns0:txBody>
+          <ns1:bodyPr/>
+          <ns1:lstStyle/>
+          <ns1:p>
+            <ns1:r>
+              <ns1:t/>
+            </ns1:r>
+          </ns1:p>
+        </ns0:txBody>
+      </ns0:sp>
+      <ns0:sp>
+        <ns0:nvSpPr>
+          <ns0:cNvPr id="4" name="Slide Number Placeholder 3"/>
+          <ns0:cNvSpPr>
+            <ns1:spLocks noGrp="1"/>
+          </ns0:cNvSpPr>
+          <ns0:nvPr>
+            <ns0:ph type="sldNum" idx="5" sz="quarter"/>
+          </ns0:nvPr>
+        </ns0:nvSpPr>
+        <ns0:spPr/>
+      </ns0:sp>
+    </ns0:spTree>
+  </ns0:cSld>
+  <ns0:clrMapOvr>
+    <ns1:masterClrMapping/>
+  </ns0:clrMapOvr>
+</ns0:notes>
 </file>
 
 <file path=ppt/notesSlides/notesSlide4.xml><?xml version="1.0" encoding="utf-8"?>
-<p:notes xmlns:a="http://schemas.openxmlformats.org/drawingml/2006/main" xmlns:p="http://schemas.openxmlformats.org/presentationml/2006/main" xmlns:r="http://schemas.openxmlformats.org/officeDocument/2006/relationships">
-  <p:cSld>
-    <p:spTree>
-      <p:nvGrpSpPr>
-        <p:cNvPr id="1" name=""/>
-        <p:cNvGrpSpPr/>
-        <p:nvPr/>
-      </p:nvGrpSpPr>
-      <p:grpSpPr>
-        <a:xfrm>
-          <a:off x="0" y="0"/>
-          <a:ext cx="0" cy="0"/>
-          <a:chOff x="0" y="0"/>
-          <a:chExt cx="0" cy="0"/>
-        </a:xfrm>
-      </p:grpSpPr>
-      <p:sp>
-        <p:nvSpPr>
-          <p:cNvPr id="2" name="Slide Image Placeholder 1"/>
-          <p:cNvSpPr>
-            <a:spLocks noGrp="1"/>
-          </p:cNvSpPr>
-          <p:nvPr>
-            <p:ph type="sldImg" idx="2"/>
-          </p:nvPr>
-        </p:nvSpPr>
-        <p:spPr/>
-      </p:sp>
-      <p:sp>
-        <p:nvSpPr>
-          <p:cNvPr id="3" name="Notes Placeholder 2"/>
-          <p:cNvSpPr>
-            <a:spLocks noGrp="1"/>
-          </p:cNvSpPr>
-          <p:nvPr>
-            <p:ph type="body" idx="3" sz="quarter"/>
-          </p:nvPr>
-        </p:nvSpPr>
-        <p:spPr/>
-        <p:txBody>
-          <a:bodyPr/>
-          <a:lstStyle/>
-          <a:p>
-            <a:r>
-              <a:t>Piyasa verisi ATK CLI’dan TR sitesi ve JSON çıktısıyla geliyor; logger yirmi paritenin epizodik hafızasını altmış saniye aralıkla tutuyor. Deterministik metrikler kaymayı ve derinliği hesaplıyor, geçmiş medyanla piyasa rejimini karşılaştırıyor, LLM de bu araçların kullanımını planlıyor. Sonuç EIP-191 ile imzalanıp Fuji’de denetleniyor; piyasa verisi için yüz yirmi saniyelik eşik ve kontrattaki üç yüz saniyelik imza penceresi ayrı kontroller.</a:t>
-            </a:r>
-          </a:p>
-        </p:txBody>
-      </p:sp>
-      <p:sp>
-        <p:nvSpPr>
-          <p:cNvPr id="4" name="Slide Number Placeholder 3"/>
-          <p:cNvSpPr>
-            <a:spLocks noGrp="1"/>
-          </p:cNvSpPr>
-          <p:nvPr>
-            <p:ph type="sldNum" idx="5" sz="quarter"/>
-          </p:nvPr>
-        </p:nvSpPr>
-        <p:spPr/>
-      </p:sp>
-    </p:spTree>
-  </p:cSld>
-  <p:clrMapOvr>
-    <a:masterClrMapping/>
-  </p:clrMapOvr>
-</p:notes>
+<ns0:notes xmlns:ns0="http://schemas.openxmlformats.org/presentationml/2006/main" xmlns:ns1="http://schemas.openxmlformats.org/drawingml/2006/main">
+  <ns0:cSld>
+    <ns0:spTree>
+      <ns0:nvGrpSpPr>
+        <ns0:cNvPr id="1" name=""/>
+        <ns0:cNvGrpSpPr/>
+        <ns0:nvPr/>
+      </ns0:nvGrpSpPr>
+      <ns0:grpSpPr>
+        <ns1:xfrm>
+          <ns1:off x="0" y="0"/>
+          <ns1:ext cx="0" cy="0"/>
+          <ns1:chOff x="0" y="0"/>
+          <ns1:chExt cx="0" cy="0"/>
+        </ns1:xfrm>
+      </ns0:grpSpPr>
+      <ns0:sp>
+        <ns0:nvSpPr>
+          <ns0:cNvPr id="2" name="Slide Image Placeholder 1"/>
+          <ns0:cNvSpPr>
+            <ns1:spLocks noGrp="1"/>
+          </ns0:cNvSpPr>
+          <ns0:nvPr>
+            <ns0:ph type="sldImg" idx="2"/>
+          </ns0:nvPr>
+        </ns0:nvSpPr>
+        <ns0:spPr/>
+      </ns0:sp>
+      <ns0:sp>
+        <ns0:nvSpPr>
+          <ns0:cNvPr id="3" name="Notes Placeholder 2"/>
+          <ns0:cNvSpPr>
+            <ns1:spLocks noGrp="1"/>
+          </ns0:cNvSpPr>
+          <ns0:nvPr>
+            <ns0:ph type="body" idx="3" sz="quarter"/>
+          </ns0:nvPr>
+        </ns0:nvSpPr>
+        <ns0:spPr/>
+        <ns0:txBody>
+          <ns1:bodyPr/>
+          <ns1:lstStyle/>
+          <ns1:p>
+            <ns1:r>
+              <ns1:t/>
+            </ns1:r>
+          </ns1:p>
+        </ns0:txBody>
+      </ns0:sp>
+      <ns0:sp>
+        <ns0:nvSpPr>
+          <ns0:cNvPr id="4" name="Slide Number Placeholder 3"/>
+          <ns0:cNvSpPr>
+            <ns1:spLocks noGrp="1"/>
+          </ns0:cNvSpPr>
+          <ns0:nvPr>
+            <ns0:ph type="sldNum" idx="5" sz="quarter"/>
+          </ns0:nvPr>
+        </ns0:nvSpPr>
+        <ns0:spPr/>
+      </ns0:sp>
+    </ns0:spTree>
+  </ns0:cSld>
+  <ns0:clrMapOvr>
+    <ns1:masterClrMapping/>
+  </ns0:clrMapOvr>
+</ns0:notes>
 </file>
 
 <file path=ppt/notesSlides/notesSlide5.xml><?xml version="1.0" encoding="utf-8"?>
-<p:notes xmlns:a="http://schemas.openxmlformats.org/drawingml/2006/main" xmlns:p="http://schemas.openxmlformats.org/presentationml/2006/main" xmlns:r="http://schemas.openxmlformats.org/officeDocument/2006/relationships">
-  <p:cSld>
-    <p:spTree>
-      <p:nvGrpSpPr>
-        <p:cNvPr id="1" name=""/>
-        <p:cNvGrpSpPr/>
-        <p:nvPr/>
-      </p:nvGrpSpPr>
-      <p:grpSpPr>
-        <a:xfrm>
-          <a:off x="0" y="0"/>
-          <a:ext cx="0" cy="0"/>
-          <a:chOff x="0" y="0"/>
-          <a:chExt cx="0" cy="0"/>
-        </a:xfrm>
-      </p:grpSpPr>
-      <p:sp>
-        <p:nvSpPr>
-          <p:cNvPr id="2" name="Slide Image Placeholder 1"/>
-          <p:cNvSpPr>
-            <a:spLocks noGrp="1"/>
-          </p:cNvSpPr>
-          <p:nvPr>
-            <p:ph type="sldImg" idx="2"/>
-          </p:nvPr>
-        </p:nvSpPr>
-        <p:spPr/>
-      </p:sp>
-      <p:sp>
-        <p:nvSpPr>
-          <p:cNvPr id="3" name="Notes Placeholder 2"/>
-          <p:cNvSpPr>
-            <a:spLocks noGrp="1"/>
-          </p:cNvSpPr>
-          <p:nvPr>
-            <p:ph type="body" idx="3" sz="quarter"/>
-          </p:nvPr>
-        </p:nvSpPr>
-        <p:spPr/>
-        <p:txBody>
-          <a:bodyPr/>
-          <a:lstStyle/>
-          <a:p>
-            <a:r>
-              <a:t>Agentic taraf, hangi kanıta hangi araçla bakılacağını seçen LLM planlayıcı; scan_market, get_candles, get_orderbook, compute_metric ve argümansız sign_score araçlarını kullanıyor. Sayılar deterministik hesaplanıyor, karar birleştirmede yalnızca daha muhafazakâr öneri kazanıyor ve sağlayıcılar çalışmazsa deterministik yedek plan devreye giriyor. Dürüst sınır şu: kontrat LLM karar etiketini değil imzalı sayıları denetler, dolayısıyla entegratör uygulama kararını da uygulamalı; serbest kullanıcı metni LLM’e gönderilmez.</a:t>
-            </a:r>
-          </a:p>
-        </p:txBody>
-      </p:sp>
-      <p:sp>
-        <p:nvSpPr>
-          <p:cNvPr id="4" name="Slide Number Placeholder 3"/>
-          <p:cNvSpPr>
-            <a:spLocks noGrp="1"/>
-          </p:cNvSpPr>
-          <p:nvPr>
-            <p:ph type="sldNum" idx="5" sz="quarter"/>
-          </p:nvPr>
-        </p:nvSpPr>
-        <p:spPr/>
-      </p:sp>
-    </p:spTree>
-  </p:cSld>
-  <p:clrMapOvr>
-    <a:masterClrMapping/>
-  </p:clrMapOvr>
-</p:notes>
+<ns0:notes xmlns:ns0="http://schemas.openxmlformats.org/presentationml/2006/main" xmlns:ns1="http://schemas.openxmlformats.org/drawingml/2006/main">
+  <ns0:cSld>
+    <ns0:spTree>
+      <ns0:nvGrpSpPr>
+        <ns0:cNvPr id="1" name=""/>
+        <ns0:cNvGrpSpPr/>
+        <ns0:nvPr/>
+      </ns0:nvGrpSpPr>
+      <ns0:grpSpPr>
+        <ns1:xfrm>
+          <ns1:off x="0" y="0"/>
+          <ns1:ext cx="0" cy="0"/>
+          <ns1:chOff x="0" y="0"/>
+          <ns1:chExt cx="0" cy="0"/>
+        </ns1:xfrm>
+      </ns0:grpSpPr>
+      <ns0:sp>
+        <ns0:nvSpPr>
+          <ns0:cNvPr id="2" name="Slide Image Placeholder 1"/>
+          <ns0:cNvSpPr>
+            <ns1:spLocks noGrp="1"/>
+          </ns0:cNvSpPr>
+          <ns0:nvPr>
+            <ns0:ph type="sldImg" idx="2"/>
+          </ns0:nvPr>
+        </ns0:nvSpPr>
+        <ns0:spPr/>
+      </ns0:sp>
+      <ns0:sp>
+        <ns0:nvSpPr>
+          <ns0:cNvPr id="3" name="Notes Placeholder 2"/>
+          <ns0:cNvSpPr>
+            <ns1:spLocks noGrp="1"/>
+          </ns0:cNvSpPr>
+          <ns0:nvPr>
+            <ns0:ph type="body" idx="3" sz="quarter"/>
+          </ns0:nvPr>
+        </ns0:nvSpPr>
+        <ns0:spPr/>
+        <ns0:txBody>
+          <ns1:bodyPr/>
+          <ns1:lstStyle/>
+          <ns1:p>
+            <ns1:r>
+              <ns1:t/>
+            </ns1:r>
+          </ns1:p>
+        </ns0:txBody>
+      </ns0:sp>
+      <ns0:sp>
+        <ns0:nvSpPr>
+          <ns0:cNvPr id="4" name="Slide Number Placeholder 3"/>
+          <ns0:cNvSpPr>
+            <ns1:spLocks noGrp="1"/>
+          </ns0:cNvSpPr>
+          <ns0:nvPr>
+            <ns0:ph type="sldNum" idx="5" sz="quarter"/>
+          </ns0:nvPr>
+        </ns0:nvSpPr>
+        <ns0:spPr/>
+      </ns0:sp>
+    </ns0:spTree>
+  </ns0:cSld>
+  <ns0:clrMapOvr>
+    <ns1:masterClrMapping/>
+  </ns0:clrMapOvr>
+</ns0:notes>
 </file>
 
 <file path=ppt/notesSlides/notesSlide6.xml><?xml version="1.0" encoding="utf-8"?>
-<p:notes xmlns:a="http://schemas.openxmlformats.org/drawingml/2006/main" xmlns:p="http://schemas.openxmlformats.org/presentationml/2006/main" xmlns:r="http://schemas.openxmlformats.org/officeDocument/2006/relationships">
-  <p:cSld>
-    <p:spTree>
-      <p:nvGrpSpPr>
-        <p:cNvPr id="1" name=""/>
-        <p:cNvGrpSpPr/>
-        <p:nvPr/>
-      </p:nvGrpSpPr>
-      <p:grpSpPr>
-        <a:xfrm>
-          <a:off x="0" y="0"/>
-          <a:ext cx="0" cy="0"/>
-          <a:chOff x="0" y="0"/>
-          <a:chExt cx="0" cy="0"/>
-        </a:xfrm>
-      </p:grpSpPr>
-      <p:sp>
-        <p:nvSpPr>
-          <p:cNvPr id="2" name="Slide Image Placeholder 1"/>
-          <p:cNvSpPr>
-            <a:spLocks noGrp="1"/>
-          </p:cNvSpPr>
-          <p:nvPr>
-            <p:ph type="sldImg" idx="2"/>
-          </p:nvPr>
-        </p:nvSpPr>
-        <p:spPr/>
-      </p:sp>
-      <p:sp>
-        <p:nvSpPr>
-          <p:cNvPr id="3" name="Notes Placeholder 2"/>
-          <p:cNvSpPr>
-            <a:spLocks noGrp="1"/>
-          </p:cNvSpPr>
-          <p:nvPr>
-            <p:ph type="body" idx="3" sz="quarter"/>
-          </p:nvPr>
-        </p:nvSpPr>
-        <p:spPr/>
-        <p:txBody>
-          <a:bodyPr/>
-          <a:lstStyle/>
-          <a:p>
-            <a:r>
-              <a:t>Şimdi yerel uygulamada önce bin USDT niyetini açıp karar izini, güvenli tutarı ve imzayı gösteriyorum; tahta uygunsa sonuç onay, canlı veri değiştiğinde sonuç da değişebilir. Sonra on bin USDT niyetinde güvenli tutar aşılırsa ExceedsSafeSize ve N parçaya bölme önerisini karşılaştırıyorum; N’yi önceden sabitlemiyorum, agent ve kontrat aynı yukarı yuvarlama hesabını kullanıyor. Üçüncü sahne açıkça veri kesintisi simülasyonu: oracle imza üretmiyor ve trader’ın kendi imzası BadSigner alıyor; varsayılan yerel kontrat cevabı eth_call ön izlemesi, gerçek işlem kanıtları ayrı ve internet sürümü yalnızca kayıtlı örnekleri gösteriyor.</a:t>
-            </a:r>
-          </a:p>
-        </p:txBody>
-      </p:sp>
-      <p:sp>
-        <p:nvSpPr>
-          <p:cNvPr id="4" name="Slide Number Placeholder 3"/>
-          <p:cNvSpPr>
-            <a:spLocks noGrp="1"/>
-          </p:cNvSpPr>
-          <p:nvPr>
-            <p:ph type="sldNum" idx="5" sz="quarter"/>
-          </p:nvPr>
-        </p:nvSpPr>
-        <p:spPr/>
-      </p:sp>
-    </p:spTree>
-  </p:cSld>
-  <p:clrMapOvr>
-    <a:masterClrMapping/>
-  </p:clrMapOvr>
-</p:notes>
+<ns0:notes xmlns:ns0="http://schemas.openxmlformats.org/presentationml/2006/main" xmlns:ns1="http://schemas.openxmlformats.org/drawingml/2006/main">
+  <ns0:cSld>
+    <ns0:spTree>
+      <ns0:nvGrpSpPr>
+        <ns0:cNvPr id="1" name=""/>
+        <ns0:cNvGrpSpPr/>
+        <ns0:nvPr/>
+      </ns0:nvGrpSpPr>
+      <ns0:grpSpPr>
+        <ns1:xfrm>
+          <ns1:off x="0" y="0"/>
+          <ns1:ext cx="0" cy="0"/>
+          <ns1:chOff x="0" y="0"/>
+          <ns1:chExt cx="0" cy="0"/>
+        </ns1:xfrm>
+      </ns0:grpSpPr>
+      <ns0:sp>
+        <ns0:nvSpPr>
+          <ns0:cNvPr id="2" name="Slide Image Placeholder 1"/>
+          <ns0:cNvSpPr>
+            <ns1:spLocks noGrp="1"/>
+          </ns0:cNvSpPr>
+          <ns0:nvPr>
+            <ns0:ph type="sldImg" idx="2"/>
+          </ns0:nvPr>
+        </ns0:nvSpPr>
+        <ns0:spPr/>
+      </ns0:sp>
+      <ns0:sp>
+        <ns0:nvSpPr>
+          <ns0:cNvPr id="3" name="Notes Placeholder 2"/>
+          <ns0:cNvSpPr>
+            <ns1:spLocks noGrp="1"/>
+          </ns0:cNvSpPr>
+          <ns0:nvPr>
+            <ns0:ph type="body" idx="3" sz="quarter"/>
+          </ns0:nvPr>
+        </ns0:nvSpPr>
+        <ns0:spPr/>
+        <ns0:txBody>
+          <ns1:bodyPr/>
+          <ns1:lstStyle/>
+          <ns1:p>
+            <ns1:r>
+              <ns1:t/>
+            </ns1:r>
+          </ns1:p>
+        </ns0:txBody>
+      </ns0:sp>
+      <ns0:sp>
+        <ns0:nvSpPr>
+          <ns0:cNvPr id="4" name="Slide Number Placeholder 3"/>
+          <ns0:cNvSpPr>
+            <ns1:spLocks noGrp="1"/>
+          </ns0:cNvSpPr>
+          <ns0:nvPr>
+            <ns0:ph type="sldNum" idx="5" sz="quarter"/>
+          </ns0:nvPr>
+        </ns0:nvSpPr>
+        <ns0:spPr/>
+      </ns0:sp>
+    </ns0:spTree>
+  </ns0:cSld>
+  <ns0:clrMapOvr>
+    <ns1:masterClrMapping/>
+  </ns0:clrMapOvr>
+</ns0:notes>
 </file>
 
 <file path=ppt/notesSlides/notesSlide7.xml><?xml version="1.0" encoding="utf-8"?>
-<p:notes xmlns:a="http://schemas.openxmlformats.org/drawingml/2006/main" xmlns:p="http://schemas.openxmlformats.org/presentationml/2006/main" xmlns:r="http://schemas.openxmlformats.org/officeDocument/2006/relationships">
-  <p:cSld>
-    <p:spTree>
-      <p:nvGrpSpPr>
-        <p:cNvPr id="1" name=""/>
-        <p:cNvGrpSpPr/>
-        <p:nvPr/>
-      </p:nvGrpSpPr>
-      <p:grpSpPr>
-        <a:xfrm>
-          <a:off x="0" y="0"/>
-          <a:ext cx="0" cy="0"/>
-          <a:chOff x="0" y="0"/>
-          <a:chExt cx="0" cy="0"/>
-        </a:xfrm>
-      </p:grpSpPr>
-      <p:sp>
-        <p:nvSpPr>
-          <p:cNvPr id="2" name="Slide Image Placeholder 1"/>
-          <p:cNvSpPr>
-            <a:spLocks noGrp="1"/>
-          </p:cNvSpPr>
-          <p:nvPr>
-            <p:ph type="sldImg" idx="2"/>
-          </p:nvPr>
-        </p:nvSpPr>
-        <p:spPr/>
-      </p:sp>
-      <p:sp>
-        <p:nvSpPr>
-          <p:cNvPr id="3" name="Notes Placeholder 2"/>
-          <p:cNvSpPr>
-            <a:spLocks noGrp="1"/>
-          </p:cNvSpPr>
-          <p:nvPr>
-            <p:ph type="body" idx="3" sz="quarter"/>
-          </p:nvPr>
-        </p:nvSpPr>
-        <p:spPr/>
-        <p:txBody>
-          <a:bodyPr/>
-          <a:lstStyle/>
-          <a:p>
-            <a:r>
-              <a:t>Kötü senaryoda önce veri kesintisini gösteriyorum: imza yok, yetkisiz imza BadSigner alıyor; replay’de ise kontrat önce tazeliğe baktığı için eski kullanılmış onay StaleScore, geçerlilik penceresindeki kullanılmış onay AlreadyUsed alıyor ve iki yol da gerçek tx ile kaydedildi. Oracle anahtarı çalınırsa owner pause ve setOracle ile müdahale edebiliyor, ama tek oracle güveni devam ediyor. LLM için yapısal veri ve deterministik sayılar, yanlış alarm için parametrik eşik ve nominal Bonferroni düzeltmesi var; gerçek yanlış alarm oranını ölçtüğümü söylemiyorum ve acil çıkış yolu yalnızca kavram.</a:t>
-            </a:r>
-          </a:p>
-        </p:txBody>
-      </p:sp>
-      <p:sp>
-        <p:nvSpPr>
-          <p:cNvPr id="4" name="Slide Number Placeholder 3"/>
-          <p:cNvSpPr>
-            <a:spLocks noGrp="1"/>
-          </p:cNvSpPr>
-          <p:nvPr>
-            <p:ph type="sldNum" idx="5" sz="quarter"/>
-          </p:nvPr>
-        </p:nvSpPr>
-        <p:spPr/>
-      </p:sp>
-    </p:spTree>
-  </p:cSld>
-  <p:clrMapOvr>
-    <a:masterClrMapping/>
-  </p:clrMapOvr>
-</p:notes>
+<ns0:notes xmlns:ns0="http://schemas.openxmlformats.org/presentationml/2006/main" xmlns:ns1="http://schemas.openxmlformats.org/drawingml/2006/main">
+  <ns0:cSld>
+    <ns0:spTree>
+      <ns0:nvGrpSpPr>
+        <ns0:cNvPr id="1" name=""/>
+        <ns0:cNvGrpSpPr/>
+        <ns0:nvPr/>
+      </ns0:nvGrpSpPr>
+      <ns0:grpSpPr>
+        <ns1:xfrm>
+          <ns1:off x="0" y="0"/>
+          <ns1:ext cx="0" cy="0"/>
+          <ns1:chOff x="0" y="0"/>
+          <ns1:chExt cx="0" cy="0"/>
+        </ns1:xfrm>
+      </ns0:grpSpPr>
+      <ns0:sp>
+        <ns0:nvSpPr>
+          <ns0:cNvPr id="2" name="Slide Image Placeholder 1"/>
+          <ns0:cNvSpPr>
+            <ns1:spLocks noGrp="1"/>
+          </ns0:cNvSpPr>
+          <ns0:nvPr>
+            <ns0:ph type="sldImg" idx="2"/>
+          </ns0:nvPr>
+        </ns0:nvSpPr>
+        <ns0:spPr/>
+      </ns0:sp>
+      <ns0:sp>
+        <ns0:nvSpPr>
+          <ns0:cNvPr id="3" name="Notes Placeholder 2"/>
+          <ns0:cNvSpPr>
+            <ns1:spLocks noGrp="1"/>
+          </ns0:cNvSpPr>
+          <ns0:nvPr>
+            <ns0:ph type="body" idx="3" sz="quarter"/>
+          </ns0:nvPr>
+        </ns0:nvSpPr>
+        <ns0:spPr/>
+        <ns0:txBody>
+          <ns1:bodyPr/>
+          <ns1:lstStyle/>
+          <ns1:p>
+            <ns1:r>
+              <ns1:t/>
+            </ns1:r>
+          </ns1:p>
+        </ns0:txBody>
+      </ns0:sp>
+      <ns0:sp>
+        <ns0:nvSpPr>
+          <ns0:cNvPr id="4" name="Slide Number Placeholder 3"/>
+          <ns0:cNvSpPr>
+            <ns1:spLocks noGrp="1"/>
+          </ns0:cNvSpPr>
+          <ns0:nvPr>
+            <ns0:ph type="sldNum" idx="5" sz="quarter"/>
+          </ns0:nvPr>
+        </ns0:nvSpPr>
+        <ns0:spPr/>
+      </ns0:sp>
+    </ns0:spTree>
+  </ns0:cSld>
+  <ns0:clrMapOvr>
+    <ns1:masterClrMapping/>
+  </ns0:clrMapOvr>
+</ns0:notes>
 </file>
 
 <file path=ppt/notesSlides/notesSlide8.xml><?xml version="1.0" encoding="utf-8"?>
-<p:notes xmlns:a="http://schemas.openxmlformats.org/drawingml/2006/main" xmlns:p="http://schemas.openxmlformats.org/presentationml/2006/main" xmlns:r="http://schemas.openxmlformats.org/officeDocument/2006/relationships">
-  <p:cSld>
-    <p:spTree>
-      <p:nvGrpSpPr>
-        <p:cNvPr id="1" name=""/>
-        <p:cNvGrpSpPr/>
-        <p:nvPr/>
-      </p:nvGrpSpPr>
-      <p:grpSpPr>
-        <a:xfrm>
-          <a:off x="0" y="0"/>
-          <a:ext cx="0" cy="0"/>
-          <a:chOff x="0" y="0"/>
-          <a:chExt cx="0" cy="0"/>
-        </a:xfrm>
-      </p:grpSpPr>
-      <p:sp>
-        <p:nvSpPr>
-          <p:cNvPr id="2" name="Slide Image Placeholder 1"/>
-          <p:cNvSpPr>
-            <a:spLocks noGrp="1"/>
-          </p:cNvSpPr>
-          <p:nvPr>
-            <p:ph type="sldImg" idx="2"/>
-          </p:nvPr>
-        </p:nvSpPr>
-        <p:spPr/>
-      </p:sp>
-      <p:sp>
-        <p:nvSpPr>
-          <p:cNvPr id="3" name="Notes Placeholder 2"/>
-          <p:cNvSpPr>
-            <a:spLocks noGrp="1"/>
-          </p:cNvSpPr>
-          <p:nvPr>
-            <p:ph type="body" idx="3" sz="quarter"/>
-          </p:nvPr>
-        </p:nvSpPr>
-        <p:spPr/>
-        <p:txBody>
-          <a:bodyPr/>
-          <a:lstStyle/>
-          <a:p>
-            <a:r>
-              <a:t>Ana kanıt listesinde yedi gerçek işlem var: IntentApproved kayıtları ve demo kapsamındaki ExceedsSafeSize, BadSigner, AlreadyUsed ve StaleScore kontrolleri; taze replay için bir USDT hazırlık işlemi ayrıca kullanıldı. Tablodaki işlem kimlikleri tıklanabilir, Python testlerinin güncel sayısı seksen yedi ve Solidity için on dört test kaydı var; burada Python koşuları ortam dosyası okunmadan, açık kontrat adresiyle doğrulandı, Solidity sayısı STATUS kaydından geliyor. Yaklaşık iki saniye zincir onayı ve koşu başına yaklaşık 0,001 USD LLM maliyeti proje kayıtlarına dayanıyor, bütün uygulamanın iki saniyede tamamlandığı anlamına gelmiyor; tek oracle ve testnet sınırları devam ediyor, risk ağırlıkları tasarım tercihi.</a:t>
-            </a:r>
-          </a:p>
-        </p:txBody>
-      </p:sp>
-      <p:sp>
-        <p:nvSpPr>
-          <p:cNvPr id="4" name="Slide Number Placeholder 3"/>
-          <p:cNvSpPr>
-            <a:spLocks noGrp="1"/>
-          </p:cNvSpPr>
-          <p:nvPr>
-            <p:ph type="sldNum" idx="5" sz="quarter"/>
-          </p:nvPr>
-        </p:nvSpPr>
-        <p:spPr/>
-      </p:sp>
-    </p:spTree>
-  </p:cSld>
-  <p:clrMapOvr>
-    <a:masterClrMapping/>
-  </p:clrMapOvr>
-</p:notes>
+<ns0:notes xmlns:ns0="http://schemas.openxmlformats.org/presentationml/2006/main" xmlns:ns1="http://schemas.openxmlformats.org/drawingml/2006/main">
+  <ns0:cSld>
+    <ns0:spTree>
+      <ns0:nvGrpSpPr>
+        <ns0:cNvPr id="1" name=""/>
+        <ns0:cNvGrpSpPr/>
+        <ns0:nvPr/>
+      </ns0:nvGrpSpPr>
+      <ns0:grpSpPr>
+        <ns1:xfrm>
+          <ns1:off x="0" y="0"/>
+          <ns1:ext cx="0" cy="0"/>
+          <ns1:chOff x="0" y="0"/>
+          <ns1:chExt cx="0" cy="0"/>
+        </ns1:xfrm>
+      </ns0:grpSpPr>
+      <ns0:sp>
+        <ns0:nvSpPr>
+          <ns0:cNvPr id="2" name="Slide Image Placeholder 1"/>
+          <ns0:cNvSpPr>
+            <ns1:spLocks noGrp="1"/>
+          </ns0:cNvSpPr>
+          <ns0:nvPr>
+            <ns0:ph type="sldImg" idx="2"/>
+          </ns0:nvPr>
+        </ns0:nvSpPr>
+        <ns0:spPr/>
+      </ns0:sp>
+      <ns0:sp>
+        <ns0:nvSpPr>
+          <ns0:cNvPr id="3" name="Notes Placeholder 2"/>
+          <ns0:cNvSpPr>
+            <ns1:spLocks noGrp="1"/>
+          </ns0:cNvSpPr>
+          <ns0:nvPr>
+            <ns0:ph type="body" idx="3" sz="quarter"/>
+          </ns0:nvPr>
+        </ns0:nvSpPr>
+        <ns0:spPr/>
+        <ns0:txBody>
+          <ns1:bodyPr/>
+          <ns1:lstStyle/>
+          <ns1:p>
+            <ns1:r>
+              <ns1:t/>
+            </ns1:r>
+          </ns1:p>
+        </ns0:txBody>
+      </ns0:sp>
+      <ns0:sp>
+        <ns0:nvSpPr>
+          <ns0:cNvPr id="4" name="Slide Number Placeholder 3"/>
+          <ns0:cNvSpPr>
+            <ns1:spLocks noGrp="1"/>
+          </ns0:cNvSpPr>
+          <ns0:nvPr>
+            <ns0:ph type="sldNum" idx="5" sz="quarter"/>
+          </ns0:nvPr>
+        </ns0:nvSpPr>
+        <ns0:spPr/>
+      </ns0:sp>
+    </ns0:spTree>
+  </ns0:cSld>
+  <ns0:clrMapOvr>
+    <ns1:masterClrMapping/>
+  </ns0:clrMapOvr>
+</ns0:notes>
 </file>
 
 <file path=ppt/notesSlides/notesSlide9.xml><?xml version="1.0" encoding="utf-8"?>
-<p:notes xmlns:a="http://schemas.openxmlformats.org/drawingml/2006/main" xmlns:p="http://schemas.openxmlformats.org/presentationml/2006/main" xmlns:r="http://schemas.openxmlformats.org/officeDocument/2006/relationships">
-  <p:cSld>
-    <p:spTree>
-      <p:nvGrpSpPr>
-        <p:cNvPr id="1" name=""/>
-        <p:cNvGrpSpPr/>
-        <p:nvPr/>
-      </p:nvGrpSpPr>
-      <p:grpSpPr>
-        <a:xfrm>
-          <a:off x="0" y="0"/>
-          <a:ext cx="0" cy="0"/>
-          <a:chOff x="0" y="0"/>
-          <a:chExt cx="0" cy="0"/>
-        </a:xfrm>
-      </p:grpSpPr>
-      <p:sp>
-        <p:nvSpPr>
-          <p:cNvPr id="2" name="Slide Image Placeholder 1"/>
-          <p:cNvSpPr>
-            <a:spLocks noGrp="1"/>
-          </p:cNvSpPr>
-          <p:nvPr>
-            <p:ph type="sldImg" idx="2"/>
-          </p:nvPr>
-        </p:nvSpPr>
-        <p:spPr/>
-      </p:sp>
-      <p:sp>
-        <p:nvSpPr>
-          <p:cNvPr id="3" name="Notes Placeholder 2"/>
-          <p:cNvSpPr>
-            <a:spLocks noGrp="1"/>
-          </p:cNvSpPr>
-          <p:nvPr>
-            <p:ph type="body" idx="3" sz="quarter"/>
-          </p:nvPr>
-        </p:nvSpPr>
-        <p:spPr/>
-        <p:txBody>
-          <a:bodyPr/>
-          <a:lstStyle/>
-          <a:p>
-            <a:r>
-              <a:t>Bugün yerelde çalışan canlı ATK ve imzalı skor akışı, Fuji kontratı ve paylaşılabilir bir internet simülasyonu var; internet sürümü kayıtlı örnekler kullanıyor, yeni veri veya imza üretmiyor. Hedef müşteri ATK ile agent geliştiren ekipler ve bireyler, tasarlanan iş modeli temel kontrolü ücretsiz tutup gerçek zamanlı API erişimini ücretlendirmek ama fiyat ve ödeme isteği henüz doğrulanmadı. Çoklu oracle, eşik imza, EIP-712, Almgren–Chriss icra planı, OKX.ai listeleme ve çağrı başına ödeme sonraki adımlar; bunları bugün kodlanmış özellik gibi sunmuyorum.</a:t>
-            </a:r>
-          </a:p>
-        </p:txBody>
-      </p:sp>
-      <p:sp>
-        <p:nvSpPr>
-          <p:cNvPr id="4" name="Slide Number Placeholder 3"/>
-          <p:cNvSpPr>
-            <a:spLocks noGrp="1"/>
-          </p:cNvSpPr>
-          <p:nvPr>
-            <p:ph type="sldNum" idx="5" sz="quarter"/>
-          </p:nvPr>
-        </p:nvSpPr>
-        <p:spPr/>
-      </p:sp>
-    </p:spTree>
-  </p:cSld>
-  <p:clrMapOvr>
-    <a:masterClrMapping/>
-  </p:clrMapOvr>
-</p:notes>
+<ns0:notes xmlns:ns0="http://schemas.openxmlformats.org/presentationml/2006/main" xmlns:ns1="http://schemas.openxmlformats.org/drawingml/2006/main">
+  <ns0:cSld>
+    <ns0:spTree>
+      <ns0:nvGrpSpPr>
+        <ns0:cNvPr id="1" name=""/>
+        <ns0:cNvGrpSpPr/>
+        <ns0:nvPr/>
+      </ns0:nvGrpSpPr>
+      <ns0:grpSpPr>
+        <ns1:xfrm>
+          <ns1:off x="0" y="0"/>
+          <ns1:ext cx="0" cy="0"/>
+          <ns1:chOff x="0" y="0"/>
+          <ns1:chExt cx="0" cy="0"/>
+        </ns1:xfrm>
+      </ns0:grpSpPr>
+      <ns0:sp>
+        <ns0:nvSpPr>
+          <ns0:cNvPr id="2" name="Slide Image Placeholder 1"/>
+          <ns0:cNvSpPr>
+            <ns1:spLocks noGrp="1"/>
+          </ns0:cNvSpPr>
+          <ns0:nvPr>
+            <ns0:ph type="sldImg" idx="2"/>
+          </ns0:nvPr>
+        </ns0:nvSpPr>
+        <ns0:spPr/>
+      </ns0:sp>
+      <ns0:sp>
+        <ns0:nvSpPr>
+          <ns0:cNvPr id="3" name="Notes Placeholder 2"/>
+          <ns0:cNvSpPr>
+            <ns1:spLocks noGrp="1"/>
+          </ns0:cNvSpPr>
+          <ns0:nvPr>
+            <ns0:ph type="body" idx="3" sz="quarter"/>
+          </ns0:nvPr>
+        </ns0:nvSpPr>
+        <ns0:spPr/>
+        <ns0:txBody>
+          <ns1:bodyPr/>
+          <ns1:lstStyle/>
+          <ns1:p>
+            <ns1:r>
+              <ns1:t/>
+            </ns1:r>
+          </ns1:p>
+        </ns0:txBody>
+      </ns0:sp>
+      <ns0:sp>
+        <ns0:nvSpPr>
+          <ns0:cNvPr id="4" name="Slide Number Placeholder 3"/>
+          <ns0:cNvSpPr>
+            <ns1:spLocks noGrp="1"/>
+          </ns0:cNvSpPr>
+          <ns0:nvPr>
+            <ns0:ph type="sldNum" idx="5" sz="quarter"/>
+          </ns0:nvPr>
+        </ns0:nvSpPr>
+        <ns0:spPr/>
+      </ns0:sp>
+    </ns0:spTree>
+  </ns0:cSld>
+  <ns0:clrMapOvr>
+    <ns1:masterClrMapping/>
+  </ns0:clrMapOvr>
+</ns0:notes>
 </file>
 
 <file path=ppt/slideLayouts/slideLayout1.xml><?xml version="1.0" encoding="utf-8"?>

</xml_diff>